<commit_message>
Plainer wording in docs and slides, no colons or dashes in prose
</commit_message>
<xml_diff>
--- a/docs/submission/GreenCharge-Autopilot-VelesHack.pptx
+++ b/docs/submission/GreenCharge-Autopilot-VelesHack.pptx
@@ -5377,7 +5377,7 @@
             </a:pPr>
             <a:r>
               <a:rPr sz="1400"/>
-              <a:t>ENACT policies that change the running app, and prove it</a:t>
+              <a:t>ENACT policies that change the running app, with proof that it worked</a:t>
             </a:r>
             <a:endParaRPr/>
           </a:p>
@@ -5385,7 +5385,7 @@
             <a:pPr/>
             <a:r>
               <a:rPr sz="1400"/>
-              <a:t>Challenge 3 (ENACT): Kubernetes Dynamic Adaptation  ·  Team: Harrie</a:t>
+              <a:t>Challenge 3 (ENACT), Kubernetes Dynamic Adaptation  ·  Team Harrie</a:t>
             </a:r>
           </a:p>
         </p:txBody>
@@ -5530,7 +5530,7 @@
             </a:pPr>
             <a:r>
               <a:rPr sz="1600"/>
-              <a:t>GitHub repo: https://github.com/IamHarrie-Labs/greencharge-autopilot</a:t>
+              <a:t>github.com/IamHarrie-Labs/greencharge-autopilot</a:t>
             </a:r>
             <a:endParaRPr/>
           </a:p>
@@ -5538,7 +5538,7 @@
             <a:pPr/>
             <a:r>
               <a:rPr sz="1600"/>
-              <a:t>Run it: make setup → make operator-fix → make deploy → make autopilot-ui</a:t>
+              <a:t>To run it, use make setup, then make operator-fix, make deploy and make autopilot-ui</a:t>
             </a:r>
           </a:p>
           <a:p>
@@ -5552,28 +5552,28 @@
             <a:pPr lvl="1"/>
             <a:r>
               <a:rPr sz="1500"/>
-              <a:t>greencharge/: GreenCharge + ENACT Application Controller (policy model, compliance) + Autopilot</a:t>
+              <a:t>greencharge/ holds the app, the ENACT Application Controller setup (policy model and compliance) and the autopilot</a:t>
             </a:r>
           </a:p>
           <a:p>
             <a:pPr lvl="1"/>
             <a:r>
               <a:rPr sz="1500"/>
-              <a:t>operator-fix/: patch to the ENACT policy operator (metrics auth, Hard-rule bug), with tests</a:t>
+              <a:t>operator-fix/ holds our patch to the ENACT policy operator for metrics login and a Hard rule bug, with tests</a:t>
             </a:r>
           </a:p>
           <a:p>
             <a:pPr lvl="1"/>
             <a:r>
               <a:rPr sz="1500"/>
-              <a:t>docs/evidence/: every adaptation recorded on the live cluster; dataspace transfer records</a:t>
+              <a:t>docs/evidence/ holds every adaptation recorded on the live cluster and the dataspace transfer records</a:t>
             </a:r>
           </a:p>
           <a:p>
             <a:pPr lvl="1"/>
             <a:r>
               <a:rPr sz="1500"/>
-              <a:t>Apache-2.0 · 13 Java + 4 Go tests</a:t>
+              <a:t>Apache-2.0 · 13 Java tests and 4 Go tests</a:t>
             </a:r>
           </a:p>
         </p:txBody>
@@ -5746,7 +5746,7 @@
             </a:pPr>
             <a:r>
               <a:rPr sz="1400"/>
-              <a:t>ENACT says what a workload should look like: the Application Controller recommends scale_up / scale_down, the policy operator picks a node. Nothing then changes the running app, and in the hackathon cluster the operator could not decide at all (TDCME returned 401).</a:t>
+              <a:t>ENACT says what a workload should look like. The Application Controller recommends scale_up or scale_down and the policy operator picks a node. Nothing then changes the running app, and in the hackathon cluster the operator could not decide anything because TDCME refused it with 401.</a:t>
             </a:r>
             <a:endParaRPr/>
           </a:p>
@@ -5754,35 +5754,35 @@
             <a:pPr/>
             <a:r>
               <a:rPr sz="1400"/>
-              <a:t>We closed the loop</a:t>
+              <a:t>What we built</a:t>
             </a:r>
           </a:p>
           <a:p>
             <a:pPr lvl="1"/>
             <a:r>
               <a:rPr sz="1300"/>
-              <a:t>Fixed the ENACT operator: token auth, a Hard-rule bug that re-ranked nodes every 30 s, explained rejections</a:t>
+              <a:t>A fix for the ENACT operator. It now logs in with a token, stops ranking nodes again every 30 s because of a Hard rule bug, and explains each rejection</a:t>
             </a:r>
           </a:p>
           <a:p>
             <a:pPr lvl="1"/>
             <a:r>
               <a:rPr sz="1300"/>
-              <a:t>GreenCharge Autopilot: detect → decide (ENACT AC + operator) → guard (Hard rules, cooldown) → apply → verify (rollout + health) → roll back</a:t>
+              <a:t>GreenCharge Autopilot detects a problem, takes the decision from ENACT, checks it against the Hard rules, applies it, verifies the rollout and health, and rolls back if needed</a:t>
             </a:r>
           </a:p>
           <a:p>
             <a:pPr lvl="1"/>
             <a:r>
               <a:rPr sz="1300"/>
-              <a:t>Evidence timeline: what was measured, what ENACT decided, what changed, whether the app recovered</a:t>
+              <a:t>An evidence log showing what was measured, what ENACT decided, what changed and whether the app recovered</a:t>
             </a:r>
           </a:p>
           <a:p>
             <a:pPr lvl="1"/>
             <a:r>
               <a:rPr sz="1300"/>
-              <a:t>ENACT SDK, scripted: Application Packaging (Helm chart), Application Policies (CRD-valid), Dataspaces (negotiation FINALIZED, transfer COMPLETED; relay download blocked)</a:t>
+              <a:t>The ENACT SDK libraries run from scripts. Packaging builds the Helm chart, the policy passes the CRD check, and the dataspace negotiation and transfer complete. Only the download from the organisers' relay is blocked</a:t>
             </a:r>
           </a:p>
         </p:txBody>
@@ -5955,7 +5955,7 @@
             </a:pPr>
             <a:r>
               <a:rPr sz="1400"/>
-              <a:t>Measured on the challenge's own 3-node kind cluster</a:t>
+              <a:t>Measured on the challenge's own 3 node kind cluster</a:t>
             </a:r>
             <a:endParaRPr/>
           </a:p>
@@ -5963,49 +5963,49 @@
             <a:pPr lvl="1"/>
             <a:r>
               <a:rPr sz="1300"/>
-              <a:t>Out-of-policy app (0.5 CPU, wrong node) → adapted and verified in 105 s</a:t>
+              <a:t>An app outside its policy (0.5 CPU on the wrong node) was adapted and verified in 105 s</a:t>
             </a:r>
           </a:p>
           <a:p>
             <a:pPr lvl="1"/>
             <a:r>
               <a:rPr sz="1300"/>
-              <a:t>Move to a node outside eu-west → rejected by the Hard rule, app untouched</a:t>
+              <a:t>A move to a node outside eu-west was refused by the Hard rule and the app was left alone</a:t>
             </a:r>
           </a:p>
           <a:p>
             <a:pPr lvl="1"/>
             <a:r>
               <a:rPr sz="1300"/>
-              <a:t>Change that cannot become healthy → rolled back in 100 s, reverting only its own fields</a:t>
+              <a:t>A change that could never become healthy was rolled back in 100 s, undoing only its own settings</a:t>
             </a:r>
           </a:p>
           <a:p>
             <a:pPr lvl="1"/>
             <a:r>
               <a:rPr sz="1300"/>
-              <a:t>Node leaves eu-west → operator re-decides, app moves; no flapping afterwards</a:t>
+              <a:t>When a node left eu-west the operator picked again, the app moved, and nothing flipped back afterwards</a:t>
             </a:r>
           </a:p>
           <a:p>
             <a:pPr lvl="1"/>
             <a:r>
               <a:rPr sz="1300"/>
-              <a:t>Edge-role policy → GreenCharge lands on enact-dev-worker, as the brief requires</a:t>
+              <a:t>With the edge role policy GreenCharge runs on enact-dev-worker, as the brief asks</a:t>
             </a:r>
           </a:p>
           <a:p>
             <a:pPr/>
             <a:r>
               <a:rPr sz="1400"/>
-              <a:t>Running it for real found 3 bugs in our own design (rollback that overwrote Helm, wrong rollout test, rejected patch as HTTP 500): all fixed and tested</a:t>
+              <a:t>Running it for real exposed 3 bugs in our own design (a rollback that undid Helm's change, the wrong rollout check, a refused patch shown as HTTP 500). All three are fixed and tested</a:t>
             </a:r>
           </a:p>
           <a:p>
             <a:pPr lvl="1"/>
             <a:r>
               <a:rPr sz="1300"/>
-              <a:t>ENACT SDK libraries drive packaging, policy validation and the dataspace flow: one command each</a:t>
+              <a:t>The ENACT SDK libraries handle packaging, policy validation and the dataspace flow, with one command each</a:t>
             </a:r>
           </a:p>
         </p:txBody>

</xml_diff>

<commit_message>
Load test with Prometheus and Kepler results, summary up front, organiser guides moved to docs/organisers
</commit_message>
<xml_diff>
--- a/docs/submission/GreenCharge-Autopilot-VelesHack.pptx
+++ b/docs/submission/GreenCharge-Autopilot-VelesHack.pptx
@@ -5745,7 +5745,7 @@
               <a:buChar char="●"/>
             </a:pPr>
             <a:r>
-              <a:rPr sz="1400"/>
+              <a:rPr sz="1300"/>
               <a:t>ENACT says what a workload should look like. The Application Controller recommends scale_up or scale_down and the policy operator picks a node. Nothing then changes the running app, and in the hackathon cluster the operator could not decide anything because TDCME refused it with 401.</a:t>
             </a:r>
             <a:endParaRPr/>
@@ -5753,35 +5753,35 @@
           <a:p>
             <a:pPr/>
             <a:r>
-              <a:rPr sz="1400"/>
+              <a:rPr sz="1300"/>
               <a:t>What we built</a:t>
             </a:r>
           </a:p>
           <a:p>
             <a:pPr lvl="1"/>
             <a:r>
-              <a:rPr sz="1300"/>
+              <a:rPr sz="1200"/>
               <a:t>A fix for the ENACT operator. It now logs in with a token, stops ranking nodes again every 30 s because of a Hard rule bug, and explains each rejection</a:t>
             </a:r>
           </a:p>
           <a:p>
             <a:pPr lvl="1"/>
             <a:r>
-              <a:rPr sz="1300"/>
+              <a:rPr sz="1200"/>
               <a:t>GreenCharge Autopilot detects a problem, takes the decision from ENACT, checks it against the Hard rules, applies it, verifies the rollout and health, and rolls back if needed</a:t>
             </a:r>
           </a:p>
           <a:p>
             <a:pPr lvl="1"/>
             <a:r>
-              <a:rPr sz="1300"/>
+              <a:rPr sz="1200"/>
               <a:t>An evidence log showing what was measured, what ENACT decided, what changed and whether the app recovered</a:t>
             </a:r>
           </a:p>
           <a:p>
             <a:pPr lvl="1"/>
             <a:r>
-              <a:rPr sz="1300"/>
+              <a:rPr sz="1200"/>
               <a:t>The ENACT SDK libraries run from scripts. Packaging builds the Helm chart, the policy passes the CRD check, and the dataspace negotiation and transfer complete. Only the download from the organisers' relay is blocked</a:t>
             </a:r>
           </a:p>

</xml_diff>